<commit_message>
Fix modify at 2025-05-30
</commit_message>
<xml_diff>
--- a/FinML/Course-project/Course project.pptx
+++ b/FinML/Course-project/Course project.pptx
@@ -130,7 +130,7 @@
           <a:p>
             <a:fld id="{CED1C788-56A1-2E45-A024-5C42A74F7F0E}" type="datetimeFigureOut">
               <a:rPr lang="en-US" smtClean="0"/>
-              <a:t>3/10/25</a:t>
+              <a:t>5/29/25</a:t>
             </a:fld>
             <a:endParaRPr lang="en-US"/>
           </a:p>
@@ -1990,7 +1990,7 @@
           <a:p>
             <a:fld id="{1D8BD707-D9CF-40AE-B4C6-C98DA3205C09}" type="datetimeFigureOut">
               <a:rPr lang="en-US"/>
-              <a:t>3/10/25</a:t>
+              <a:t>5/29/25</a:t>
             </a:fld>
             <a:endParaRPr lang="en-US"/>
           </a:p>
@@ -2167,7 +2167,7 @@
           <a:p>
             <a:fld id="{1D8BD707-D9CF-40AE-B4C6-C98DA3205C09}" type="datetimeFigureOut">
               <a:rPr lang="en-US"/>
-              <a:t>3/10/25</a:t>
+              <a:t>5/29/25</a:t>
             </a:fld>
             <a:endParaRPr lang="en-US"/>
           </a:p>
@@ -2393,7 +2393,7 @@
           <a:p>
             <a:fld id="{1D8BD707-D9CF-40AE-B4C6-C98DA3205C09}" type="datetimeFigureOut">
               <a:rPr lang="en-US"/>
-              <a:t>3/10/25</a:t>
+              <a:t>5/29/25</a:t>
             </a:fld>
             <a:endParaRPr lang="en-US"/>
           </a:p>
@@ -2571,7 +2571,7 @@
           <a:p>
             <a:fld id="{1D8BD707-D9CF-40AE-B4C6-C98DA3205C09}" type="datetimeFigureOut">
               <a:rPr lang="en-US"/>
-              <a:t>3/10/25</a:t>
+              <a:t>5/29/25</a:t>
             </a:fld>
             <a:endParaRPr lang="en-US"/>
           </a:p>
@@ -2690,7 +2690,7 @@
           <a:p>
             <a:fld id="{1D8BD707-D9CF-40AE-B4C6-C98DA3205C09}" type="datetimeFigureOut">
               <a:rPr lang="en-US"/>
-              <a:t>3/10/25</a:t>
+              <a:t>5/29/25</a:t>
             </a:fld>
             <a:endParaRPr lang="en-US"/>
           </a:p>
@@ -4842,7 +4842,7 @@
           <a:p>
             <a:fld id="{1D8BD707-D9CF-40AE-B4C6-C98DA3205C09}" type="datetimeFigureOut">
               <a:rPr lang="en-US"/>
-              <a:t>3/10/25</a:t>
+              <a:t>5/29/25</a:t>
             </a:fld>
             <a:endParaRPr lang="en-US"/>
           </a:p>
@@ -5279,25 +5279,32 @@
               </a:spcBef>
             </a:pPr>
             <a:r>
+              <a:rPr lang="ru-RU" sz="1400" dirty="0">
+                <a:latin typeface="Calibri"/>
+                <a:cs typeface="Calibri"/>
+              </a:rPr>
+              <a:t>29</a:t>
+            </a:r>
+            <a:r>
+              <a:rPr sz="1400" dirty="0">
+                <a:latin typeface="Calibri"/>
+                <a:cs typeface="Calibri"/>
+              </a:rPr>
+              <a:t>.</a:t>
+            </a:r>
+            <a:r>
               <a:rPr lang="en-US" sz="1400" dirty="0">
                 <a:latin typeface="Calibri"/>
                 <a:cs typeface="Calibri"/>
               </a:rPr>
-              <a:t>10</a:t>
-            </a:r>
-            <a:r>
-              <a:rPr sz="1400" dirty="0">
+              <a:t>0</a:t>
+            </a:r>
+            <a:r>
+              <a:rPr lang="ru-RU" sz="1400" dirty="0">
                 <a:latin typeface="Calibri"/>
                 <a:cs typeface="Calibri"/>
               </a:rPr>
-              <a:t>.</a:t>
-            </a:r>
-            <a:r>
-              <a:rPr lang="en-US" sz="1400" dirty="0">
-                <a:latin typeface="Calibri"/>
-                <a:cs typeface="Calibri"/>
-              </a:rPr>
-              <a:t>03</a:t>
+              <a:t>5</a:t>
             </a:r>
             <a:r>
               <a:rPr sz="1400" spc="-40" dirty="0">
@@ -5356,25 +5363,32 @@
               </a:spcBef>
             </a:pPr>
             <a:r>
+              <a:rPr lang="ru-RU" sz="1400" dirty="0">
+                <a:latin typeface="Calibri"/>
+                <a:cs typeface="Calibri"/>
+              </a:rPr>
+              <a:t>27</a:t>
+            </a:r>
+            <a:r>
+              <a:rPr sz="1400" dirty="0">
+                <a:latin typeface="Calibri"/>
+                <a:cs typeface="Calibri"/>
+              </a:rPr>
+              <a:t>.</a:t>
+            </a:r>
+            <a:r>
               <a:rPr lang="en-US" sz="1400" dirty="0">
                 <a:latin typeface="Calibri"/>
                 <a:cs typeface="Calibri"/>
               </a:rPr>
-              <a:t>05</a:t>
-            </a:r>
-            <a:r>
-              <a:rPr sz="1400" dirty="0">
+              <a:t>0</a:t>
+            </a:r>
+            <a:r>
+              <a:rPr lang="ru-RU" sz="1400" dirty="0">
                 <a:latin typeface="Calibri"/>
                 <a:cs typeface="Calibri"/>
               </a:rPr>
-              <a:t>.</a:t>
-            </a:r>
-            <a:r>
-              <a:rPr lang="en-US" sz="1400" dirty="0">
-                <a:latin typeface="Calibri"/>
-                <a:cs typeface="Calibri"/>
-              </a:rPr>
-              <a:t>04</a:t>
+              <a:t>6</a:t>
             </a:r>
             <a:r>
               <a:rPr sz="1400" spc="-35" dirty="0">
@@ -5924,211 +5938,6 @@
           </a:fontRef>
         </p:style>
       </p:cxnSp>
-      <p:graphicFrame>
-        <p:nvGraphicFramePr>
-          <p:cNvPr id="24" name="Table 23">
-            <a:extLst>
-              <a:ext uri="{FF2B5EF4-FFF2-40B4-BE49-F238E27FC236}">
-                <a16:creationId xmlns:a16="http://schemas.microsoft.com/office/drawing/2014/main" id="{548FFE73-08C7-6147-B60A-390BA5C5E546}"/>
-              </a:ext>
-            </a:extLst>
-          </p:cNvPr>
-          <p:cNvGraphicFramePr>
-            <a:graphicFrameLocks noGrp="1"/>
-          </p:cNvGraphicFramePr>
-          <p:nvPr>
-            <p:extLst>
-              <p:ext uri="{D42A27DB-BD31-4B8C-83A1-F6EECF244321}">
-                <p14:modId xmlns:p14="http://schemas.microsoft.com/office/powerpoint/2010/main" val="4226505594"/>
-              </p:ext>
-            </p:extLst>
-          </p:nvPr>
-        </p:nvGraphicFramePr>
-        <p:xfrm>
-          <a:off x="5355768" y="573874"/>
-          <a:ext cx="2226910" cy="365760"/>
-        </p:xfrm>
-        <a:graphic>
-          <a:graphicData uri="http://schemas.openxmlformats.org/drawingml/2006/table">
-            <a:tbl>
-              <a:tblPr firstRow="1" bandRow="1"/>
-              <a:tblGrid>
-                <a:gridCol w="445382">
-                  <a:extLst>
-                    <a:ext uri="{9D8B030D-6E8A-4147-A177-3AD203B41FA5}">
-                      <a16:colId xmlns:a16="http://schemas.microsoft.com/office/drawing/2014/main" val="884960188"/>
-                    </a:ext>
-                  </a:extLst>
-                </a:gridCol>
-                <a:gridCol w="445382">
-                  <a:extLst>
-                    <a:ext uri="{9D8B030D-6E8A-4147-A177-3AD203B41FA5}">
-                      <a16:colId xmlns:a16="http://schemas.microsoft.com/office/drawing/2014/main" val="1334008315"/>
-                    </a:ext>
-                  </a:extLst>
-                </a:gridCol>
-                <a:gridCol w="445382">
-                  <a:extLst>
-                    <a:ext uri="{9D8B030D-6E8A-4147-A177-3AD203B41FA5}">
-                      <a16:colId xmlns:a16="http://schemas.microsoft.com/office/drawing/2014/main" val="3209860974"/>
-                    </a:ext>
-                  </a:extLst>
-                </a:gridCol>
-                <a:gridCol w="445382">
-                  <a:extLst>
-                    <a:ext uri="{9D8B030D-6E8A-4147-A177-3AD203B41FA5}">
-                      <a16:colId xmlns:a16="http://schemas.microsoft.com/office/drawing/2014/main" val="4238538779"/>
-                    </a:ext>
-                  </a:extLst>
-                </a:gridCol>
-                <a:gridCol w="445382">
-                  <a:extLst>
-                    <a:ext uri="{9D8B030D-6E8A-4147-A177-3AD203B41FA5}">
-                      <a16:colId xmlns:a16="http://schemas.microsoft.com/office/drawing/2014/main" val="4263781807"/>
-                    </a:ext>
-                  </a:extLst>
-                </a:gridCol>
-              </a:tblGrid>
-              <a:tr h="250242">
-                <a:tc>
-                  <a:txBody>
-                    <a:bodyPr/>
-                    <a:lstStyle/>
-                    <a:p>
-                      <a:pPr algn="ctr"/>
-                      <a:r>
-                        <a:rPr lang="en-US" dirty="0">
-                          <a:solidFill>
-                            <a:schemeClr val="tx1">
-                              <a:lumMod val="50000"/>
-                              <a:lumOff val="50000"/>
-                            </a:schemeClr>
-                          </a:solidFill>
-                        </a:rPr>
-                        <a:t>1</a:t>
-                      </a:r>
-                    </a:p>
-                  </a:txBody>
-                  <a:tcPr>
-                    <a:solidFill>
-                      <a:schemeClr val="bg1">
-                        <a:lumMod val="85000"/>
-                      </a:schemeClr>
-                    </a:solidFill>
-                  </a:tcPr>
-                </a:tc>
-                <a:tc>
-                  <a:txBody>
-                    <a:bodyPr/>
-                    <a:lstStyle/>
-                    <a:p>
-                      <a:pPr algn="ctr"/>
-                      <a:r>
-                        <a:rPr lang="en-US" dirty="0">
-                          <a:solidFill>
-                            <a:schemeClr val="tx1">
-                              <a:lumMod val="50000"/>
-                              <a:lumOff val="50000"/>
-                            </a:schemeClr>
-                          </a:solidFill>
-                        </a:rPr>
-                        <a:t>2</a:t>
-                      </a:r>
-                    </a:p>
-                  </a:txBody>
-                  <a:tcPr>
-                    <a:solidFill>
-                      <a:schemeClr val="bg1">
-                        <a:lumMod val="85000"/>
-                      </a:schemeClr>
-                    </a:solidFill>
-                  </a:tcPr>
-                </a:tc>
-                <a:tc>
-                  <a:txBody>
-                    <a:bodyPr/>
-                    <a:lstStyle/>
-                    <a:p>
-                      <a:pPr algn="ctr"/>
-                      <a:r>
-                        <a:rPr lang="en-US" dirty="0">
-                          <a:solidFill>
-                            <a:schemeClr val="tx1">
-                              <a:lumMod val="50000"/>
-                              <a:lumOff val="50000"/>
-                            </a:schemeClr>
-                          </a:solidFill>
-                        </a:rPr>
-                        <a:t>3</a:t>
-                      </a:r>
-                    </a:p>
-                  </a:txBody>
-                  <a:tcPr>
-                    <a:solidFill>
-                      <a:schemeClr val="bg1">
-                        <a:lumMod val="85000"/>
-                      </a:schemeClr>
-                    </a:solidFill>
-                  </a:tcPr>
-                </a:tc>
-                <a:tc>
-                  <a:txBody>
-                    <a:bodyPr/>
-                    <a:lstStyle/>
-                    <a:p>
-                      <a:pPr algn="ctr"/>
-                      <a:r>
-                        <a:rPr lang="en-US" dirty="0">
-                          <a:solidFill>
-                            <a:schemeClr val="tx1">
-                              <a:lumMod val="50000"/>
-                              <a:lumOff val="50000"/>
-                            </a:schemeClr>
-                          </a:solidFill>
-                        </a:rPr>
-                        <a:t>4</a:t>
-                      </a:r>
-                    </a:p>
-                  </a:txBody>
-                  <a:tcPr>
-                    <a:solidFill>
-                      <a:schemeClr val="bg1">
-                        <a:lumMod val="85000"/>
-                      </a:schemeClr>
-                    </a:solidFill>
-                  </a:tcPr>
-                </a:tc>
-                <a:tc>
-                  <a:txBody>
-                    <a:bodyPr/>
-                    <a:lstStyle/>
-                    <a:p>
-                      <a:pPr algn="ctr"/>
-                      <a:r>
-                        <a:rPr lang="en-US" dirty="0"/>
-                        <a:t>5</a:t>
-                      </a:r>
-                    </a:p>
-                  </a:txBody>
-                  <a:tcPr>
-                    <a:solidFill>
-                      <a:schemeClr val="tx2">
-                        <a:lumMod val="20000"/>
-                        <a:lumOff val="80000"/>
-                      </a:schemeClr>
-                    </a:solidFill>
-                  </a:tcPr>
-                </a:tc>
-                <a:extLst>
-                  <a:ext uri="{0D108BD9-81ED-4DB2-BD59-A6C34878D82A}">
-                    <a16:rowId xmlns:a16="http://schemas.microsoft.com/office/drawing/2014/main" val="97753204"/>
-                  </a:ext>
-                </a:extLst>
-              </a:tr>
-            </a:tbl>
-          </a:graphicData>
-        </a:graphic>
-      </p:graphicFrame>
       <p:sp>
         <p:nvSpPr>
           <p:cNvPr id="30" name="Rounded Rectangle 29">
@@ -6267,25 +6076,32 @@
               </a:spcBef>
             </a:pPr>
             <a:r>
+              <a:rPr lang="ru-RU" sz="1400" dirty="0">
+                <a:latin typeface="Calibri"/>
+                <a:cs typeface="Calibri"/>
+              </a:rPr>
+              <a:t>03</a:t>
+            </a:r>
+            <a:r>
+              <a:rPr sz="1400" dirty="0">
+                <a:latin typeface="Calibri"/>
+                <a:cs typeface="Calibri"/>
+              </a:rPr>
+              <a:t>.</a:t>
+            </a:r>
+            <a:r>
               <a:rPr lang="en-US" sz="1400" dirty="0">
                 <a:latin typeface="Calibri"/>
                 <a:cs typeface="Calibri"/>
               </a:rPr>
-              <a:t>12</a:t>
-            </a:r>
-            <a:r>
-              <a:rPr sz="1400" dirty="0">
+              <a:t>0</a:t>
+            </a:r>
+            <a:r>
+              <a:rPr lang="ru-RU" sz="1400" dirty="0">
                 <a:latin typeface="Calibri"/>
                 <a:cs typeface="Calibri"/>
               </a:rPr>
-              <a:t>.</a:t>
-            </a:r>
-            <a:r>
-              <a:rPr lang="en-US" sz="1400" dirty="0">
-                <a:latin typeface="Calibri"/>
-                <a:cs typeface="Calibri"/>
-              </a:rPr>
-              <a:t>03</a:t>
+              <a:t>6</a:t>
             </a:r>
             <a:r>
               <a:rPr sz="1400" spc="-40" dirty="0">
@@ -6323,7 +6139,7 @@
         <p:spPr>
           <a:xfrm>
             <a:off x="1233718" y="2927937"/>
-            <a:ext cx="526415" cy="228268"/>
+            <a:ext cx="652066" cy="228268"/>
           </a:xfrm>
           <a:prstGeom prst="rect">
             <a:avLst/>
@@ -6344,14 +6160,14 @@
               </a:spcBef>
             </a:pPr>
             <a:r>
-              <a:rPr lang="en-US" sz="1400" b="1" dirty="0">
+              <a:rPr lang="ru-RU" sz="1400" b="1" dirty="0">
                 <a:solidFill>
                   <a:srgbClr val="FF0000"/>
                 </a:solidFill>
                 <a:latin typeface="Calibri"/>
                 <a:cs typeface="Calibri"/>
               </a:rPr>
-              <a:t>01</a:t>
+              <a:t>19</a:t>
             </a:r>
             <a:r>
               <a:rPr sz="1400" b="1" dirty="0">
@@ -6371,27 +6187,47 @@
                 <a:latin typeface="Calibri"/>
                 <a:cs typeface="Calibri"/>
               </a:rPr>
-              <a:t>04</a:t>
-            </a:r>
-            <a:r>
-              <a:rPr sz="1400" b="1" spc="-40" dirty="0">
+              <a:t>0</a:t>
+            </a:r>
+            <a:r>
+              <a:rPr lang="ru-RU" sz="1400" b="1" dirty="0">
                 <a:solidFill>
                   <a:srgbClr val="FF0000"/>
                 </a:solidFill>
                 <a:latin typeface="Calibri"/>
                 <a:cs typeface="Calibri"/>
               </a:rPr>
-              <a:t> </a:t>
-            </a:r>
-            <a:r>
-              <a:rPr sz="1400" b="1" spc="-50" dirty="0">
+              <a:t>6</a:t>
+            </a:r>
+            <a:r>
+              <a:rPr sz="1400" b="1" spc="-40" dirty="0">
                 <a:solidFill>
                   <a:srgbClr val="FF0000"/>
                 </a:solidFill>
                 <a:latin typeface="Calibri"/>
                 <a:cs typeface="Calibri"/>
               </a:rPr>
+              <a:t> </a:t>
+            </a:r>
+            <a:r>
+              <a:rPr sz="1400" b="1" spc="-50" dirty="0">
+                <a:solidFill>
+                  <a:srgbClr val="FF0000"/>
+                </a:solidFill>
+                <a:latin typeface="Calibri"/>
+                <a:cs typeface="Calibri"/>
+              </a:rPr>
               <a:t>-</a:t>
+            </a:r>
+            <a:r>
+              <a:rPr lang="ru-RU" sz="1400" b="1" spc="-50" dirty="0">
+                <a:solidFill>
+                  <a:srgbClr val="FF0000"/>
+                </a:solidFill>
+                <a:latin typeface="Calibri"/>
+                <a:cs typeface="Calibri"/>
+              </a:rPr>
+              <a:t> ?</a:t>
             </a:r>
             <a:endParaRPr sz="1400" b="1" dirty="0">
               <a:solidFill>
@@ -6418,7 +6254,7 @@
         <p:spPr>
           <a:xfrm>
             <a:off x="1233717" y="3434129"/>
-            <a:ext cx="526415" cy="228268"/>
+            <a:ext cx="652066" cy="228268"/>
           </a:xfrm>
           <a:prstGeom prst="rect">
             <a:avLst/>
@@ -6446,47 +6282,77 @@
                 <a:latin typeface="Calibri"/>
                 <a:cs typeface="Calibri"/>
               </a:rPr>
-              <a:t>24</a:t>
-            </a:r>
-            <a:r>
-              <a:rPr sz="1400" b="1" dirty="0">
+              <a:t>2</a:t>
+            </a:r>
+            <a:r>
+              <a:rPr lang="ru-RU" sz="1400" b="1" dirty="0">
                 <a:solidFill>
                   <a:srgbClr val="FF0000"/>
                 </a:solidFill>
                 <a:latin typeface="Calibri"/>
                 <a:cs typeface="Calibri"/>
               </a:rPr>
-              <a:t>.</a:t>
-            </a:r>
-            <a:r>
-              <a:rPr lang="en-US" sz="1400" b="1" dirty="0">
+              <a:t>5</a:t>
+            </a:r>
+            <a:r>
+              <a:rPr sz="1400" b="1" dirty="0">
                 <a:solidFill>
                   <a:srgbClr val="FF0000"/>
                 </a:solidFill>
                 <a:latin typeface="Calibri"/>
                 <a:cs typeface="Calibri"/>
               </a:rPr>
-              <a:t>04</a:t>
-            </a:r>
-            <a:r>
-              <a:rPr sz="1400" b="1" spc="-40" dirty="0">
+              <a:t>.</a:t>
+            </a:r>
+            <a:r>
+              <a:rPr lang="en-US" sz="1400" b="1" dirty="0">
                 <a:solidFill>
                   <a:srgbClr val="FF0000"/>
                 </a:solidFill>
                 <a:latin typeface="Calibri"/>
                 <a:cs typeface="Calibri"/>
               </a:rPr>
-              <a:t> </a:t>
-            </a:r>
-            <a:r>
-              <a:rPr sz="1400" b="1" spc="-50" dirty="0">
+              <a:t>0</a:t>
+            </a:r>
+            <a:r>
+              <a:rPr lang="ru-RU" sz="1400" b="1" dirty="0">
                 <a:solidFill>
                   <a:srgbClr val="FF0000"/>
                 </a:solidFill>
                 <a:latin typeface="Calibri"/>
                 <a:cs typeface="Calibri"/>
               </a:rPr>
+              <a:t>6</a:t>
+            </a:r>
+            <a:r>
+              <a:rPr sz="1400" b="1" spc="-40" dirty="0">
+                <a:solidFill>
+                  <a:srgbClr val="FF0000"/>
+                </a:solidFill>
+                <a:latin typeface="Calibri"/>
+                <a:cs typeface="Calibri"/>
+              </a:rPr>
+              <a:t> </a:t>
+            </a:r>
+            <a:r>
+              <a:rPr sz="1400" b="1" spc="-50" dirty="0">
+                <a:solidFill>
+                  <a:srgbClr val="FF0000"/>
+                </a:solidFill>
+                <a:latin typeface="Calibri"/>
+                <a:cs typeface="Calibri"/>
+              </a:rPr>
               <a:t>-</a:t>
+            </a:r>
+            <a:r>
+              <a:rPr lang="ru-RU" sz="1400" b="1" spc="-50" dirty="0">
+                <a:solidFill>
+                  <a:srgbClr val="FF0000"/>
+                </a:solidFill>
+                <a:latin typeface="Calibri"/>
+                <a:cs typeface="Calibri"/>
+              </a:rPr>
+              <a:t> ?</a:t>
             </a:r>
             <a:endParaRPr sz="1400" b="1" dirty="0">
               <a:solidFill>

</xml_diff>

<commit_message>
current changes on 2026-03-12
</commit_message>
<xml_diff>
--- a/FinML/Course-project/Course project.pptx
+++ b/FinML/Course-project/Course project.pptx
@@ -130,7 +130,7 @@
           <a:p>
             <a:fld id="{CED1C788-56A1-2E45-A024-5C42A74F7F0E}" type="datetimeFigureOut">
               <a:rPr lang="en-US" smtClean="0"/>
-              <a:t>10/2/25</a:t>
+              <a:t>2/12/26</a:t>
             </a:fld>
             <a:endParaRPr lang="en-US"/>
           </a:p>
@@ -1990,7 +1990,7 @@
           <a:p>
             <a:fld id="{1D8BD707-D9CF-40AE-B4C6-C98DA3205C09}" type="datetimeFigureOut">
               <a:rPr lang="en-US"/>
-              <a:t>10/2/25</a:t>
+              <a:t>2/12/26</a:t>
             </a:fld>
             <a:endParaRPr lang="en-US"/>
           </a:p>
@@ -2167,7 +2167,7 @@
           <a:p>
             <a:fld id="{1D8BD707-D9CF-40AE-B4C6-C98DA3205C09}" type="datetimeFigureOut">
               <a:rPr lang="en-US"/>
-              <a:t>10/2/25</a:t>
+              <a:t>2/12/26</a:t>
             </a:fld>
             <a:endParaRPr lang="en-US"/>
           </a:p>
@@ -2393,7 +2393,7 @@
           <a:p>
             <a:fld id="{1D8BD707-D9CF-40AE-B4C6-C98DA3205C09}" type="datetimeFigureOut">
               <a:rPr lang="en-US"/>
-              <a:t>10/2/25</a:t>
+              <a:t>2/12/26</a:t>
             </a:fld>
             <a:endParaRPr lang="en-US"/>
           </a:p>
@@ -2571,7 +2571,7 @@
           <a:p>
             <a:fld id="{1D8BD707-D9CF-40AE-B4C6-C98DA3205C09}" type="datetimeFigureOut">
               <a:rPr lang="en-US"/>
-              <a:t>10/2/25</a:t>
+              <a:t>2/12/26</a:t>
             </a:fld>
             <a:endParaRPr lang="en-US"/>
           </a:p>
@@ -2690,7 +2690,7 @@
           <a:p>
             <a:fld id="{1D8BD707-D9CF-40AE-B4C6-C98DA3205C09}" type="datetimeFigureOut">
               <a:rPr lang="en-US"/>
-              <a:t>10/2/25</a:t>
+              <a:t>2/12/26</a:t>
             </a:fld>
             <a:endParaRPr lang="en-US"/>
           </a:p>
@@ -4842,7 +4842,7 @@
           <a:p>
             <a:fld id="{1D8BD707-D9CF-40AE-B4C6-C98DA3205C09}" type="datetimeFigureOut">
               <a:rPr lang="en-US"/>
-              <a:t>10/2/25</a:t>
+              <a:t>2/12/26</a:t>
             </a:fld>
             <a:endParaRPr lang="en-US"/>
           </a:p>
@@ -5279,11 +5279,18 @@
               </a:spcBef>
             </a:pPr>
             <a:r>
+              <a:rPr lang="en-US" sz="1400" dirty="0">
+                <a:latin typeface="Calibri"/>
+                <a:cs typeface="Calibri"/>
+              </a:rPr>
+              <a:t>1</a:t>
+            </a:r>
+            <a:r>
               <a:rPr lang="ru-RU" sz="1400" dirty="0">
                 <a:latin typeface="Calibri"/>
                 <a:cs typeface="Calibri"/>
               </a:rPr>
-              <a:t>02</a:t>
+              <a:t>2</a:t>
             </a:r>
             <a:r>
               <a:rPr sz="1400" dirty="0">
@@ -5293,18 +5300,11 @@
               <a:t>.</a:t>
             </a:r>
             <a:r>
-              <a:rPr lang="ru-RU" sz="1400" dirty="0">
-                <a:latin typeface="Calibri"/>
-                <a:cs typeface="Calibri"/>
-              </a:rPr>
-              <a:t>1</a:t>
-            </a:r>
-            <a:r>
               <a:rPr lang="en-US" sz="1400" dirty="0">
                 <a:latin typeface="Calibri"/>
                 <a:cs typeface="Calibri"/>
               </a:rPr>
-              <a:t>0</a:t>
+              <a:t>02</a:t>
             </a:r>
             <a:r>
               <a:rPr sz="1400" spc="-40" dirty="0">
@@ -5363,11 +5363,11 @@
               </a:spcBef>
             </a:pPr>
             <a:r>
-              <a:rPr lang="ru-RU" sz="1400" dirty="0">
+              <a:rPr lang="en-US" sz="1400" dirty="0">
                 <a:latin typeface="Calibri"/>
                 <a:cs typeface="Calibri"/>
               </a:rPr>
-              <a:t>02</a:t>
+              <a:t>13</a:t>
             </a:r>
             <a:r>
               <a:rPr sz="1400" dirty="0">
@@ -5377,11 +5377,11 @@
               <a:t>.</a:t>
             </a:r>
             <a:r>
-              <a:rPr lang="ru-RU" sz="1400" dirty="0">
+              <a:rPr lang="en-US" sz="1400" dirty="0">
                 <a:latin typeface="Calibri"/>
                 <a:cs typeface="Calibri"/>
               </a:rPr>
-              <a:t>12</a:t>
+              <a:t>04</a:t>
             </a:r>
             <a:r>
               <a:rPr sz="1400" spc="-35" dirty="0">
@@ -5958,7 +5958,7 @@
                 <a:latin typeface="Calibri"/>
                 <a:cs typeface="Calibri"/>
               </a:rPr>
-              <a:t>11</a:t>
+              <a:t>26</a:t>
             </a:r>
             <a:r>
               <a:rPr sz="1400" b="1" dirty="0">
@@ -5978,7 +5978,7 @@
                 <a:latin typeface="Calibri"/>
                 <a:cs typeface="Calibri"/>
               </a:rPr>
-              <a:t>11</a:t>
+              <a:t>03</a:t>
             </a:r>
             <a:r>
               <a:rPr sz="1400" b="1" spc="-40" dirty="0">
@@ -6063,37 +6063,27 @@
                 <a:latin typeface="Calibri"/>
                 <a:cs typeface="Calibri"/>
               </a:rPr>
-              <a:t>2</a:t>
-            </a:r>
-            <a:r>
-              <a:rPr lang="ru-RU" sz="1400" b="1" dirty="0">
+              <a:t>08</a:t>
+            </a:r>
+            <a:r>
+              <a:rPr sz="1400" b="1" dirty="0">
                 <a:solidFill>
                   <a:srgbClr val="FF0000"/>
                 </a:solidFill>
                 <a:latin typeface="Calibri"/>
                 <a:cs typeface="Calibri"/>
               </a:rPr>
-              <a:t>5</a:t>
-            </a:r>
-            <a:r>
-              <a:rPr sz="1400" b="1" dirty="0">
+              <a:t>.</a:t>
+            </a:r>
+            <a:r>
+              <a:rPr lang="en-US" sz="1400" b="1" dirty="0">
                 <a:solidFill>
                   <a:srgbClr val="FF0000"/>
                 </a:solidFill>
                 <a:latin typeface="Calibri"/>
                 <a:cs typeface="Calibri"/>
               </a:rPr>
-              <a:t>.</a:t>
-            </a:r>
-            <a:r>
-              <a:rPr lang="ru-RU" sz="1400" b="1" dirty="0">
-                <a:solidFill>
-                  <a:srgbClr val="FF0000"/>
-                </a:solidFill>
-                <a:latin typeface="Calibri"/>
-                <a:cs typeface="Calibri"/>
-              </a:rPr>
-              <a:t>11</a:t>
+              <a:t>04</a:t>
             </a:r>
             <a:r>
               <a:rPr sz="1400" b="1" spc="-40" dirty="0">

</xml_diff>